<commit_message>
Presentation: AI restocking slide in plain words, without formulas
Co-Authored-By: Claude Opus 5.5 <noreply@anthropic.com>
Claude-Session: https://claude.ai/code/session_01F1FCRnDHrNjivdPNRTQgPE
</commit_message>
<xml_diff>
--- a/docs/presentation/Inventory_Management_First_Review.pptx
+++ b/docs/presentation/Inventory_Management_First_Review.pptx
@@ -125,17 +125,17 @@
   <p:extLst>
     <p:ext uri="{521415D9-36F7-43E2-AB2F-B90AF26B5E84}">
       <p14:sectionLst xmlns:p14="http://schemas.microsoft.com/office/powerpoint/2010/main">
-        <p14:section name="Cover" id="{0af34d07-bca3-8b1f-85c9-3d3fc9bebe69}">
+        <p14:section name="Cover" id="{fd7cab4a-a794-1000-5c6c-39a4b4f6d7ca}">
           <p14:sldIdLst>
             <p14:sldId id="256"/>
           </p14:sldIdLst>
         </p14:section>
-        <p14:section name="Overview" id="{69194748-2c67-917d-61dc-c2302ccd9ea2}">
+        <p14:section name="Overview" id="{02fe323f-19b8-a6b6-0609-4804d0f66a88}">
           <p14:sldIdLst>
             <p14:sldId id="257"/>
           </p14:sldIdLst>
         </p14:section>
-        <p14:section name="The project" id="{64e6a5a9-c8f4-a6e6-4e73-2861f248f889}">
+        <p14:section name="The project" id="{c28de826-2ee3-7b5d-98ef-e707a4b3f74f}">
           <p14:sldIdLst>
             <p14:sldId id="258"/>
             <p14:sldId id="259"/>
@@ -145,7 +145,7 @@
             <p14:sldId id="263"/>
           </p14:sldIdLst>
         </p14:section>
-        <p14:section name="Research" id="{d24ef92d-a9ef-363c-106e-1121719f29c7}">
+        <p14:section name="Research" id="{7d6693f6-47a2-57ff-69a3-9e25ffd13476}">
           <p14:sldIdLst>
             <p14:sldId id="264"/>
             <p14:sldId id="265"/>
@@ -153,25 +153,25 @@
             <p14:sldId id="267"/>
           </p14:sldIdLst>
         </p14:section>
-        <p14:section name="Design" id="{7af23b90-cbbd-bddf-6956-2ad4610785fe}">
+        <p14:section name="Design" id="{5d71d615-bc3c-47f3-265a-24ddecd3f34a}">
           <p14:sldIdLst>
             <p14:sldId id="268"/>
             <p14:sldId id="269"/>
           </p14:sldIdLst>
         </p14:section>
-        <p14:section name="Approach" id="{0e10ac7e-398a-47ec-8934-99bec21cb1af}">
+        <p14:section name="Approach" id="{e150c1a9-e912-8480-e871-9ec51826b110}">
           <p14:sldIdLst>
             <p14:sldId id="270"/>
             <p14:sldId id="271"/>
             <p14:sldId id="272"/>
           </p14:sldIdLst>
         </p14:section>
-        <p14:section name="References" id="{232f0b6b-e8f2-d727-1203-cdc31a48e51c}">
+        <p14:section name="References" id="{614c5e06-0d58-71c2-37fd-d9df5e437373}">
           <p14:sldIdLst>
             <p14:sldId id="273"/>
           </p14:sldIdLst>
         </p14:section>
-        <p14:section name="Close" id="{dbb32328-8595-9fc5-7661-737f23e404b0}">
+        <p14:section name="Close" id="{1af84e4b-7883-9ffc-d1db-34576cd872e1}">
           <p14:sldIdLst>
             <p14:sldId id="274"/>
           </p14:sldIdLst>
@@ -12498,7 +12498,7 @@
                   <a:schemeClr val="tx1"/>
                 </a:solidFill>
               </a:rPr>
-              <a:t>Holt-Winters smoothing: level, trend and a weekly season</a:t>
+              <a:t>Learns each product’s trend and weekly pattern</a:t>
             </a:r>
             <a:endParaRPr lang="en-US" sz="1200" dirty="0"/>
           </a:p>
@@ -12516,7 +12516,7 @@
                   <a:schemeClr val="tx1"/>
                 </a:solidFill>
               </a:rPr>
-              <a:t>Festival uplift for Diwali, Ganesh Chaturthi, Eid</a:t>
+              <a:t>Plans for festivals like Diwali and Eid</a:t>
             </a:r>
             <a:endParaRPr lang="en-US" sz="1200" dirty="0"/>
           </a:p>
@@ -12534,7 +12534,7 @@
                   <a:schemeClr val="tx1"/>
                 </a:solidFill>
               </a:rPr>
-              <a:t>Accuracy measured with MAPE</a:t>
+              <a:t>Checks its accuracy against real sales</a:t>
             </a:r>
             <a:endParaRPr lang="en-US" sz="1200" dirty="0"/>
           </a:p>
@@ -12595,7 +12595,7 @@
                 <a:ea typeface="Cambria" pitchFamily="34" charset="-122"/>
                 <a:cs typeface="Cambria" pitchFamily="34" charset="-120"/>
               </a:rPr>
-              <a:t>ŷ(t+h) = ℓ(t) + h·b(t) + s(t+h−m)</a:t>
+              <a:t>Predicts what each item will sell</a:t>
             </a:r>
             <a:endParaRPr lang="en-US" sz="1200" dirty="0"/>
           </a:p>
@@ -12797,7 +12797,7 @@
                   <a:schemeClr val="tx1"/>
                 </a:solidFill>
               </a:rPr>
-              <a:t>Demand over the supplier’s lead time L</a:t>
+              <a:t>Expected sales until the supplier delivers</a:t>
             </a:r>
             <a:endParaRPr lang="en-US" sz="1200" dirty="0"/>
           </a:p>
@@ -12815,7 +12815,7 @@
                   <a:schemeClr val="tx1"/>
                 </a:solidFill>
               </a:rPr>
-              <a:t>Safety stock = z × σ × √L, z = 1.65 for 95%</a:t>
+              <a:t>Keeps a safety buffer for busy days</a:t>
             </a:r>
             <a:endParaRPr lang="en-US" sz="1200" dirty="0"/>
           </a:p>
@@ -12833,7 +12833,7 @@
                   <a:schemeClr val="tx1"/>
                 </a:solidFill>
               </a:rPr>
-              <a:t>Reorder when stock + on order ≤ reorder point</a:t>
+              <a:t>Flags items that will run short</a:t>
             </a:r>
             <a:endParaRPr lang="en-US" sz="1200" dirty="0"/>
           </a:p>
@@ -12851,7 +12851,7 @@
                   <a:schemeClr val="tx1"/>
                 </a:solidFill>
               </a:rPr>
-              <a:t>Quantity rounded to the pack, with a reason</a:t>
+              <a:t>Suggests a quantity, with a reason</a:t>
             </a:r>
             <a:endParaRPr lang="en-US" sz="1200" dirty="0"/>
           </a:p>
@@ -12912,7 +12912,7 @@
                 <a:ea typeface="Cambria" pitchFamily="34" charset="-122"/>
                 <a:cs typeface="Cambria" pitchFamily="34" charset="-120"/>
               </a:rPr>
-              <a:t>Reorder point = lead-time demand + safety stock</a:t>
+              <a:t>Order before it runs out, not after</a:t>
             </a:r>
             <a:endParaRPr lang="en-US" sz="1200" dirty="0"/>
           </a:p>

</xml_diff>